<commit_message>
Tell the README and the deck about the travel agency
The README's data section, the domain and endings sections, the offline
notes and the send-back description now describe Baltic Travel Agency: what
is real (places, airlines, hotels, SiteMinder, GetYourGuide), what is
invented (travellers, bookings, incidents), and which rules are simplified.
It records why the reflection loop's writer and reviewer - and handoff
triage - now hold their own tools, and why the reflection endings follow
from the letter policy rather than from a hash.

The deck's "what you are about to see" slide names the new setup. Rebuilt
with build_deck.py; those two lines are the only text that changed across
the 24 slides, and qa_deck.py finds no overflow.

Co-Authored-By: Claude Opus 5.5 <noreply@anthropic.com>
Claude-Session: https://claude.ai/code/session_01BLkA4VNuCkcQYXN2tA1K8c
</commit_message>
<xml_diff>
--- a/deck/from-chaos-to-symphony.pptx
+++ b/deck/from-chaos-to-symphony.pptx
@@ -13238,13 +13238,13 @@
           <a:p>
             <a:r>
               <a:rPr lang="en-GB" dirty="0"/>
-              <a:t>Baltic Freight Group — a freight forwarder with twenty shipments in trouble</a:t>
-            </a:r>
-          </a:p>
-          <a:p>
-            <a:r>
-              <a:rPr lang="en-GB" dirty="0"/>
-              <a:t>Every pattern works the same exception data</a:t>
+              <a:t>Baltic Travel Agency — a Riga travel agency with twenty bookings, thirteen in trouble</a:t>
+            </a:r>
+          </a:p>
+          <a:p>
+            <a:r>
+              <a:rPr lang="en-GB" dirty="0"/>
+              <a:t>Every pattern works the same book of trips</a:t>
             </a:r>
           </a:p>
           <a:p>

</xml_diff>